<commit_message>
Update report and defense deck screenshots
</commit_message>
<xml_diff>
--- a/project_docs/Eve_Defense_Presentation.pptx
+++ b/project_docs/Eve_Defense_Presentation.pptx
@@ -5019,7 +5019,19 @@
           <a:p>
             <a:r>
               <a:rPr lang="en-US" sz="2100"/>
-              <a:t>- Lecturer teaching workbench and OpenAI response layer.</a:t>
+              <a:t>- Upload-assisted Ask Eve questions.</a:t>
+            </a:r>
+          </a:p>
+          <a:p>
+            <a:r>
+              <a:rPr lang="en-US" sz="2100"/>
+              <a:t>- Moderated peer-note contribution and lecturer review.</a:t>
+            </a:r>
+          </a:p>
+          <a:p>
+            <a:r>
+              <a:rPr lang="en-US" sz="2100"/>
+              <a:t>- Lecturer teaching workbench, admin governance, and OpenAI response layer.</a:t>
             </a:r>
           </a:p>
         </p:txBody>
@@ -5249,6 +5261,12 @@
           <a:p>
             <a:r>
               <a:rPr lang="en-US" sz="2100"/>
+              <a:t>- Added upload-assisted questions and moderated peer notes.</a:t>
+            </a:r>
+          </a:p>
+          <a:p>
+            <a:r>
+              <a:rPr lang="en-US" sz="2100"/>
               <a:t>- Added lecturer saved-session analytics and tested the system.</a:t>
             </a:r>
           </a:p>
@@ -5482,6 +5500,12 @@
               <a:t>- OpenAI Responses API: optional natural language generation.</a:t>
             </a:r>
           </a:p>
+          <a:p>
+            <a:r>
+              <a:rPr lang="en-US" sz="2100"/>
+              <a:t>- Render: public deployment for user review.</a:t>
+            </a:r>
+          </a:p>
         </p:txBody>
       </p:sp>
     </p:spTree>
@@ -5493,7 +5517,7 @@
 </file>
 
 <file path=ppt/slides/slide17.xml><?xml version="1.0" encoding="utf-8"?>
-<p:sld xmlns:a="http://schemas.openxmlformats.org/drawingml/2006/main" xmlns:p="http://schemas.openxmlformats.org/presentationml/2006/main">
+<p:sld xmlns:a="http://schemas.openxmlformats.org/drawingml/2006/main" xmlns:p="http://schemas.openxmlformats.org/presentationml/2006/main" xmlns:r="http://schemas.openxmlformats.org/officeDocument/2006/relationships">
   <p:cSld>
     <p:spTree>
       <p:nvGrpSpPr>
@@ -5660,8 +5684,8 @@
         </p:nvSpPr>
         <p:spPr>
           <a:xfrm>
-            <a:off x="760000" y="1480000"/>
-            <a:ext cx="11380000" cy="5000000"/>
+            <a:off x="760000" y="1250000"/>
+            <a:ext cx="11380000" cy="500000"/>
           </a:xfrm>
           <a:prstGeom prst="rect">
             <a:avLst/>
@@ -5678,42 +5702,100 @@
           <a:lstStyle/>
           <a:p>
             <a:r>
-              <a:rPr lang="en-US" sz="2100"/>
-              <a:t>- Entry screen.</a:t>
-            </a:r>
-          </a:p>
-          <a:p>
-            <a:r>
-              <a:rPr lang="en-US" sz="2100"/>
-              <a:t>- Student learning progress dashboard.</a:t>
-            </a:r>
-          </a:p>
-          <a:p>
-            <a:r>
-              <a:rPr lang="en-US" sz="2100"/>
-              <a:t>- Guided learning session screen.</a:t>
-            </a:r>
-          </a:p>
-          <a:p>
-            <a:r>
-              <a:rPr lang="en-US" sz="2100"/>
-              <a:t>- Feedback history and quiz score.</a:t>
-            </a:r>
-          </a:p>
-          <a:p>
-            <a:r>
-              <a:rPr lang="en-US" sz="2100"/>
-              <a:t>- Lecturer teaching workbench.</a:t>
-            </a:r>
-          </a:p>
-          <a:p>
-            <a:r>
-              <a:rPr lang="en-US" sz="2100"/>
-              <a:t>- Admission readiness estimator and ChatGPT-style chat interface.</a:t>
-            </a:r>
-          </a:p>
-        </p:txBody>
-      </p:sp>
+              <a:rPr lang="en-US" sz="1450"/>
+              <a:t>- Personalized dashboard, Ask Eve conversation, lecturer review, and knowledge governance are shown below.</a:t>
+            </a:r>
+          </a:p>
+        </p:txBody>
+      </p:sp>
+      <p:pic>
+        <p:nvPicPr>
+          <p:cNvPr id="125" name="Personalized student dashboard"/>
+          <p:cNvPicPr/>
+          <p:nvPr/>
+        </p:nvPicPr>
+        <p:blipFill>
+          <a:blip r:embed="rIdEveDashboard"/>
+          <a:stretch>
+            <a:fillRect/>
+          </a:stretch>
+        </p:blipFill>
+        <p:spPr>
+          <a:xfrm>
+            <a:off x="1159275" y="1850000"/>
+            <a:ext cx="4321450" cy="2050000"/>
+          </a:xfrm>
+          <a:prstGeom prst="rect">
+            <a:avLst/>
+          </a:prstGeom>
+        </p:spPr>
+      </p:pic>
+      <p:pic>
+        <p:nvPicPr>
+          <p:cNvPr id="126" name="Ask Eve conversation"/>
+          <p:cNvPicPr/>
+          <p:nvPr/>
+        </p:nvPicPr>
+        <p:blipFill>
+          <a:blip r:embed="rIdEveChat"/>
+          <a:stretch>
+            <a:fillRect/>
+          </a:stretch>
+        </p:blipFill>
+        <p:spPr>
+          <a:xfrm>
+            <a:off x="6945440" y="1850000"/>
+            <a:ext cx="4309119" cy="2050000"/>
+          </a:xfrm>
+          <a:prstGeom prst="rect">
+            <a:avLst/>
+          </a:prstGeom>
+        </p:spPr>
+      </p:pic>
+      <p:pic>
+        <p:nvPicPr>
+          <p:cNvPr id="127" name="Lecturer peer-note review"/>
+          <p:cNvPicPr/>
+          <p:nvPr/>
+        </p:nvPicPr>
+        <p:blipFill>
+          <a:blip r:embed="rIdEveReview"/>
+          <a:stretch>
+            <a:fillRect/>
+          </a:stretch>
+        </p:blipFill>
+        <p:spPr>
+          <a:xfrm>
+            <a:off x="1115039" y="4250000"/>
+            <a:ext cx="4409921" cy="2050000"/>
+          </a:xfrm>
+          <a:prstGeom prst="rect">
+            <a:avLst/>
+          </a:prstGeom>
+        </p:spPr>
+      </p:pic>
+      <p:pic>
+        <p:nvPicPr>
+          <p:cNvPr id="128" name="Admin knowledge library"/>
+          <p:cNvPicPr/>
+          <p:nvPr/>
+        </p:nvPicPr>
+        <p:blipFill>
+          <a:blip r:embed="rIdEveAdmin"/>
+          <a:stretch>
+            <a:fillRect/>
+          </a:stretch>
+        </p:blipFill>
+        <p:spPr>
+          <a:xfrm>
+            <a:off x="6932585" y="4250000"/>
+            <a:ext cx="4334829" cy="2050000"/>
+          </a:xfrm>
+          <a:prstGeom prst="rect">
+            <a:avLst/>
+          </a:prstGeom>
+        </p:spPr>
+      </p:pic>
     </p:spTree>
   </p:cSld>
   <p:clrMapOvr>
@@ -5945,6 +6027,18 @@
           <a:p>
             <a:r>
               <a:rPr lang="en-US" sz="2100"/>
+              <a:t>- Upload-assisted Ask Eve used a CSC note as private context.</a:t>
+            </a:r>
+          </a:p>
+          <a:p>
+            <a:r>
+              <a:rPr lang="en-US" sz="2100"/>
+              <a:t>- Peer-note workflow kept student submissions pending until review.</a:t>
+            </a:r>
+          </a:p>
+          <a:p>
+            <a:r>
+              <a:rPr lang="en-US" sz="2100"/>
               <a:t>- Guardrails blocked unsafe requests.</a:t>
             </a:r>
           </a:p>
@@ -6157,13 +6251,13 @@
           <a:p>
             <a:r>
               <a:rPr lang="en-US" sz="2100"/>
-              <a:t>- The system demonstrates RAG, guardrails, guided learning, saved progress, and lecturer analytics.</a:t>
-            </a:r>
-          </a:p>
-          <a:p>
-            <a:r>
-              <a:rPr lang="en-US" sz="2100"/>
-              <a:t>- Recommendations: integrate official ESUI records, Canvas LMS, managed database storage, and admin content approval.</a:t>
+              <a:t>- The system demonstrates RAG, guardrails, guided learning, saved progress, uploads, moderated peer notes, knowledge governance, and lecturer analytics.</a:t>
+            </a:r>
+          </a:p>
+          <a:p>
+            <a:r>
+              <a:rPr lang="en-US" sz="2100"/>
+              <a:t>- Recommendations: integrate official ESUI records, Canvas LMS, managed database storage, official lecturer accounts, and admin content approval.</a:t>
             </a:r>
           </a:p>
         </p:txBody>
@@ -7385,6 +7479,12 @@
           <a:p>
             <a:r>
               <a:rPr lang="en-US" sz="2100"/>
+              <a:t>- Support upload-assisted learning questions and moderated peer notes.</a:t>
+            </a:r>
+          </a:p>
+          <a:p>
+            <a:r>
+              <a:rPr lang="en-US" sz="2100"/>
               <a:t>- Provide lecturer assigned-course analytics with guardrails and RAG.</a:t>
             </a:r>
           </a:p>
@@ -8500,6 +8600,18 @@
             <a:r>
               <a:rPr lang="en-US" sz="2100"/>
               <a:t>- Lecturer mode for assigned-course analytics.</a:t>
+            </a:r>
+          </a:p>
+          <a:p>
+            <a:r>
+              <a:rPr lang="en-US" sz="2100"/>
+              <a:t>- Upload-assisted Ask Eve support for student notes.</a:t>
+            </a:r>
+          </a:p>
+          <a:p>
+            <a:r>
+              <a:rPr lang="en-US" sz="2100"/>
+              <a:t>- Moderated peer notes and admin knowledge governance.</a:t>
             </a:r>
           </a:p>
           <a:p>

</xml_diff>

<commit_message>
Use report template and add system diagrams
</commit_message>
<xml_diff>
--- a/project_docs/Eve_Defense_Presentation.pptx
+++ b/project_docs/Eve_Defense_Presentation.pptx
@@ -3973,7 +3973,7 @@
 </file>
 
 <file path=ppt/slides/slide11.xml><?xml version="1.0" encoding="utf-8"?>
-<p:sld xmlns:a="http://schemas.openxmlformats.org/drawingml/2006/main" xmlns:p="http://schemas.openxmlformats.org/presentationml/2006/main">
+<p:sld xmlns:a="http://schemas.openxmlformats.org/drawingml/2006/main" xmlns:p="http://schemas.openxmlformats.org/presentationml/2006/main" xmlns:r="http://schemas.openxmlformats.org/officeDocument/2006/relationships">
   <p:cSld>
     <p:spTree>
       <p:nvGrpSpPr>
@@ -4140,8 +4140,8 @@
         </p:nvSpPr>
         <p:spPr>
           <a:xfrm>
-            <a:off x="760000" y="1480000"/>
-            <a:ext cx="11380000" cy="5000000"/>
+            <a:off x="650000" y="1700000"/>
+            <a:ext cx="4000000" cy="4300000"/>
           </a:xfrm>
           <a:prstGeom prst="rect">
             <a:avLst/>
@@ -4158,42 +4158,46 @@
           <a:lstStyle/>
           <a:p>
             <a:r>
-              <a:rPr lang="en-US" sz="2100"/>
-              <a:t>- User -&gt; Flutter Client -&gt; FastAPI Backend.</a:t>
-            </a:r>
-          </a:p>
-          <a:p>
-            <a:r>
-              <a:rPr lang="en-US" sz="2100"/>
-              <a:t>- Backend -&gt; Guardrails -&gt; Role-Based Access.</a:t>
-            </a:r>
-          </a:p>
-          <a:p>
-            <a:r>
-              <a:rPr lang="en-US" sz="2100"/>
-              <a:t>- Backend -&gt; RAG -&gt; ESUI Knowledge Base.</a:t>
-            </a:r>
-          </a:p>
-          <a:p>
-            <a:r>
-              <a:rPr lang="en-US" sz="2100"/>
-              <a:t>- Academic services -&gt; SQLite progress database.</a:t>
-            </a:r>
-          </a:p>
-          <a:p>
-            <a:r>
-              <a:rPr lang="en-US" sz="2100"/>
-              <a:t>- Optional OpenAI Responses API improves response naturalness.</a:t>
-            </a:r>
-          </a:p>
-          <a:p>
-            <a:r>
-              <a:rPr lang="en-US" sz="2100"/>
-              <a:t>- Local fallback keeps the system usable without OpenAI mode.</a:t>
-            </a:r>
-          </a:p>
-        </p:txBody>
-      </p:sp>
+              <a:rPr lang="en-US" sz="1550"/>
+              <a:t>- Flutter connects guest, student, and lecturer users to a FastAPI backend.</a:t>
+            </a:r>
+          </a:p>
+          <a:p>
+            <a:r>
+              <a:rPr lang="en-US" sz="1550"/>
+              <a:t>- Guardrails and role-based access control protect private academic data.</a:t>
+            </a:r>
+          </a:p>
+          <a:p>
+            <a:r>
+              <a:rPr lang="en-US" sz="1550"/>
+              <a:t>- RAG, academic services, SQLite, peer-note review, and OpenAI mode work together.</a:t>
+            </a:r>
+          </a:p>
+        </p:txBody>
+      </p:sp>
+      <p:pic>
+        <p:nvPicPr>
+          <p:cNvPr id="119" name="Architecture of the proposed Eve system"/>
+          <p:cNvPicPr/>
+          <p:nvPr/>
+        </p:nvPicPr>
+        <p:blipFill>
+          <a:blip r:embed="rIdEveProposedArchitecture"/>
+          <a:stretch>
+            <a:fillRect/>
+          </a:stretch>
+        </p:blipFill>
+        <p:spPr>
+          <a:xfrm>
+            <a:off x="5200000" y="1871875"/>
+            <a:ext cx="6500000" cy="3656250"/>
+          </a:xfrm>
+          <a:prstGeom prst="rect">
+            <a:avLst/>
+          </a:prstGeom>
+        </p:spPr>
+      </p:pic>
     </p:spTree>
   </p:cSld>
   <p:clrMapOvr>
@@ -4427,7 +4431,7 @@
 </file>
 
 <file path=ppt/slides/slide13.xml><?xml version="1.0" encoding="utf-8"?>
-<p:sld xmlns:a="http://schemas.openxmlformats.org/drawingml/2006/main" xmlns:p="http://schemas.openxmlformats.org/presentationml/2006/main">
+<p:sld xmlns:a="http://schemas.openxmlformats.org/drawingml/2006/main" xmlns:p="http://schemas.openxmlformats.org/presentationml/2006/main" xmlns:r="http://schemas.openxmlformats.org/officeDocument/2006/relationships">
   <p:cSld>
     <p:spTree>
       <p:nvGrpSpPr>
@@ -4746,8 +4750,8 @@
         </p:nvSpPr>
         <p:spPr>
           <a:xfrm>
-            <a:off x="760000" y="1480000"/>
-            <a:ext cx="11380000" cy="5000000"/>
+            <a:off x="650000" y="1700000"/>
+            <a:ext cx="4000000" cy="4300000"/>
           </a:xfrm>
           <a:prstGeom prst="rect">
             <a:avLst/>
@@ -4764,36 +4768,68 @@
           <a:lstStyle/>
           <a:p>
             <a:r>
-              <a:rPr lang="en-US" sz="2100"/>
-              <a:t>- Use Case Diagram: Guest, Student, Lecturer, Eve AI System.</a:t>
-            </a:r>
-          </a:p>
-          <a:p>
-            <a:r>
-              <a:rPr lang="en-US" sz="2100"/>
-              <a:t>- Data Flow Diagram: Flutter client, API, guardrails, RAG, academic services, SQLite.</a:t>
-            </a:r>
-          </a:p>
-          <a:p>
-            <a:r>
-              <a:rPr lang="en-US" sz="2100"/>
-              <a:t>- ERD: learning_sessions and learning_answers.</a:t>
-            </a:r>
-          </a:p>
-          <a:p>
-            <a:r>
-              <a:rPr lang="en-US" sz="2100"/>
-              <a:t>- Sequence Diagram: start session, submit answer, score answer, save progress.</a:t>
-            </a:r>
-          </a:p>
-          <a:p>
-            <a:r>
-              <a:rPr lang="en-US" sz="2100"/>
-              <a:t>- These diagrams are documented in Chapter Three.</a:t>
-            </a:r>
-          </a:p>
-        </p:txBody>
-      </p:sp>
+              <a:rPr lang="en-US" sz="1550"/>
+              <a:t>- Data flow shows how a request becomes a grounded Eve response.</a:t>
+            </a:r>
+          </a:p>
+          <a:p>
+            <a:r>
+              <a:rPr lang="en-US" sz="1550"/>
+              <a:t>- Storage design separates learning progress from moderated peer-note review.</a:t>
+            </a:r>
+          </a:p>
+          <a:p>
+            <a:r>
+              <a:rPr lang="en-US" sz="1550"/>
+              <a:t>- Use case, sequence, and ERD details are documented in Chapter Three.</a:t>
+            </a:r>
+          </a:p>
+        </p:txBody>
+      </p:sp>
+      <p:pic>
+        <p:nvPicPr>
+          <p:cNvPr id="121" name="Eve data flow diagram"/>
+          <p:cNvPicPr/>
+          <p:nvPr/>
+        </p:nvPicPr>
+        <p:blipFill>
+          <a:blip r:embed="rIdEveDataFlow"/>
+          <a:stretch>
+            <a:fillRect/>
+          </a:stretch>
+        </p:blipFill>
+        <p:spPr>
+          <a:xfrm>
+            <a:off x="6444444" y="1500000"/>
+            <a:ext cx="3911111" cy="2200000"/>
+          </a:xfrm>
+          <a:prstGeom prst="rect">
+            <a:avLst/>
+          </a:prstGeom>
+        </p:spPr>
+      </p:pic>
+      <p:pic>
+        <p:nvPicPr>
+          <p:cNvPr id="122" name="Eve database and storage design"/>
+          <p:cNvPicPr/>
+          <p:nvPr/>
+        </p:nvPicPr>
+        <p:blipFill>
+          <a:blip r:embed="rIdEveDatabaseErd"/>
+          <a:stretch>
+            <a:fillRect/>
+          </a:stretch>
+        </p:blipFill>
+        <p:spPr>
+          <a:xfrm>
+            <a:off x="6444444" y="4050000"/>
+            <a:ext cx="3911111" cy="2200000"/>
+          </a:xfrm>
+          <a:prstGeom prst="rect">
+            <a:avLst/>
+          </a:prstGeom>
+        </p:spPr>
+      </p:pic>
     </p:spTree>
   </p:cSld>
   <p:clrMapOvr>
@@ -8171,7 +8207,7 @@
 </file>
 
 <file path=ppt/slides/slide8.xml><?xml version="1.0" encoding="utf-8"?>
-<p:sld xmlns:a="http://schemas.openxmlformats.org/drawingml/2006/main" xmlns:p="http://schemas.openxmlformats.org/presentationml/2006/main">
+<p:sld xmlns:a="http://schemas.openxmlformats.org/drawingml/2006/main" xmlns:p="http://schemas.openxmlformats.org/presentationml/2006/main" xmlns:r="http://schemas.openxmlformats.org/officeDocument/2006/relationships">
   <p:cSld>
     <p:spTree>
       <p:nvGrpSpPr>
@@ -8338,8 +8374,8 @@
         </p:nvSpPr>
         <p:spPr>
           <a:xfrm>
-            <a:off x="760000" y="1480000"/>
-            <a:ext cx="11380000" cy="5000000"/>
+            <a:off x="650000" y="1700000"/>
+            <a:ext cx="4000000" cy="4300000"/>
           </a:xfrm>
           <a:prstGeom prst="rect">
             <a:avLst/>
@@ -8356,36 +8392,46 @@
           <a:lstStyle/>
           <a:p>
             <a:r>
-              <a:rPr lang="en-US" sz="2100"/>
-              <a:t>- Student or candidate asks office, website, lecturer, or peers.</a:t>
-            </a:r>
-          </a:p>
-          <a:p>
-            <a:r>
-              <a:rPr lang="en-US" sz="2100"/>
-              <a:t>- Information is manually searched or requested.</a:t>
-            </a:r>
-          </a:p>
-          <a:p>
-            <a:r>
-              <a:rPr lang="en-US" sz="2100"/>
-              <a:t>- Progress tracking depends on isolated scores and manual interpretation.</a:t>
-            </a:r>
-          </a:p>
-          <a:p>
-            <a:r>
-              <a:rPr lang="en-US" sz="2100"/>
-              <a:t>- Lecturer intervention depends on delayed or fragmented data.</a:t>
-            </a:r>
-          </a:p>
-          <a:p>
-            <a:r>
-              <a:rPr lang="en-US" sz="2100"/>
-              <a:t>- Weaknesses: slow feedback, scattered data, limited personalization, privacy risk.</a:t>
-            </a:r>
-          </a:p>
-        </p:txBody>
-      </p:sp>
+              <a:rPr lang="en-US" sz="1550"/>
+              <a:t>- Information is scattered across website, portal, offices, lecturers, course materials, and peers.</a:t>
+            </a:r>
+          </a:p>
+          <a:p>
+            <a:r>
+              <a:rPr lang="en-US" sz="1550"/>
+              <a:t>- The student must manually search across several sources.</a:t>
+            </a:r>
+          </a:p>
+          <a:p>
+            <a:r>
+              <a:rPr lang="en-US" sz="1550"/>
+              <a:t>- There is limited personalization, delayed feedback, and no continuous progress tracking.</a:t>
+            </a:r>
+          </a:p>
+        </p:txBody>
+      </p:sp>
+      <p:pic>
+        <p:nvPicPr>
+          <p:cNvPr id="116" name="Architecture of the existing system"/>
+          <p:cNvPicPr/>
+          <p:nvPr/>
+        </p:nvPicPr>
+        <p:blipFill>
+          <a:blip r:embed="rIdEveExistingArchitecture"/>
+          <a:stretch>
+            <a:fillRect/>
+          </a:stretch>
+        </p:blipFill>
+        <p:spPr>
+          <a:xfrm>
+            <a:off x="5200000" y="1871875"/>
+            <a:ext cx="6500000" cy="3656250"/>
+          </a:xfrm>
+          <a:prstGeom prst="rect">
+            <a:avLst/>
+          </a:prstGeom>
+        </p:spPr>
+      </p:pic>
     </p:spTree>
   </p:cSld>
   <p:clrMapOvr>

</xml_diff>